<commit_message>
Use multilingual SigLIP results on the week4 multilingual practice slide
Co-Authored-By: Claude Opus 5.5 <noreply@anthropic.com>
Claude-Session: https://claude.ai/code/session_015Nhg5qXXwECmBoHH8LayqG
</commit_message>
<xml_diff>
--- a/week4-siglip/김가은/SigLIP_4주차_발표.pptx
+++ b/week4-siglip/김가은/SigLIP_4주차_발표.pptx
@@ -130,14 +130,14 @@
   <p:extLst>
     <p:ext uri="{521415D9-36F7-43E2-AB2F-B90AF26B5E84}">
       <p14:sectionLst xmlns:p14="http://schemas.microsoft.com/office/powerpoint/2010/main">
-        <p14:section name="도입" id="{39ae13d3-5ce1-8b69-2a31-19c9b2a9c01e}">
+        <p14:section name="도입" id="{5a4cbd6d-93d5-57af-b157-bcdb6717fa73}">
           <p14:sldIdLst>
             <p14:sldId id="256"/>
             <p14:sldId id="257"/>
             <p14:sldId id="258"/>
           </p14:sldIdLst>
         </p14:section>
-        <p14:section name="배경: 대조학습" id="{a4631b60-7256-86fd-fb77-9d30f9f396b2}">
+        <p14:section name="배경: 대조학습" id="{80d862f2-2d55-801b-5676-27e9bcd70a2e}">
           <p14:sldIdLst>
             <p14:sldId id="259"/>
             <p14:sldId id="260"/>
@@ -145,7 +145,7 @@
             <p14:sldId id="262"/>
           </p14:sldIdLst>
         </p14:section>
-        <p14:section name="SigLIP 핵심" id="{44ae4f9e-b9b8-591a-524f-c993ba4ab386}">
+        <p14:section name="SigLIP 핵심" id="{9c7f61d5-eac1-2c59-aaf5-c309fa575623}">
           <p14:sldIdLst>
             <p14:sldId id="263"/>
             <p14:sldId id="264"/>
@@ -156,13 +156,13 @@
             <p14:sldId id="269"/>
           </p14:sldIdLst>
         </p14:section>
-        <p14:section name="검색에 적합한 이유" id="{d7eaa629-3c75-4863-eab6-9e371012d33f}">
+        <p14:section name="검색에 적합한 이유" id="{fb2f7821-1607-f69b-8c58-dc0a43df6c1f}">
           <p14:sldIdLst>
             <p14:sldId id="270"/>
             <p14:sldId id="271"/>
           </p14:sldIdLst>
         </p14:section>
-        <p14:section name="실습" id="{1e873515-e7a1-f1ce-f320-4fd73ba0bfc6}">
+        <p14:section name="실습" id="{8ff9cedf-c4e1-1afc-3b8b-526d06890c45}">
           <p14:sldIdLst>
             <p14:sldId id="272"/>
             <p14:sldId id="273"/>
@@ -172,7 +172,7 @@
             <p14:sldId id="277"/>
           </p14:sldIdLst>
         </p14:section>
-        <p14:section name="마무리" id="{fea26faf-d0bc-3f19-8d5c-23b857d722f7}">
+        <p14:section name="마무리" id="{44060433-0d20-7a3c-a505-af45d446c4d0}">
           <p14:sldIdLst>
             <p14:sldId id="278"/>
             <p14:sldId id="279"/>
@@ -2425,10 +2425,11 @@
           <a:p>
             <a:r>
               <a:rPr lang="en-US" dirty="0"/>
-              <a:t>다음은 다국어 예제입니다. 프랑스어, 네덜란드어, 독일어 문장을 넣어 봤고, 프랑스어 '고양이 두 마리 사진'이 29.5%, 나머지는 0%가 나왔습니다.
-그런데 짚을 점이 하나 있어요. 노트북의 다국어 셀에서 모델을 새로 불러오는 부분이 주석 처리되어 있어서, 이 결과는 다국어 모델이 아니라 앞에서 불러온 영어 base 모델로 나온 겁니다.
-영어 모델인데도 프랑스어 문장을 어느 정도 맞힌 셈이에요.
-제대로 비교하려면 google/siglip-base-patch16-256-multilingual을 불러와서 다시 돌려야 하고, 한국어 질문도 이 모델로 실험해 보면 5주차에 바로 쓸 수 있습니다.</a:t>
+              <a:t>다음은 다국어 예제입니다. 이번에는 다국어 체크포인트인 siglip-base-patch16-256-multilingual을 불러왔습니다. 논문에서 mSigLIP이라고 부르는 모델로, 영어로 거르지 않은 데이터로 학습했고 어휘가 25만 토큰이라 한국어도 다룰 수 있습니다.
+제대로 불러왔는지는 출력으로 확인할 수 있어요. 이 모델은 입력 해상도가 256이라서 pixel_values가 256×256으로 나옵니다. 모델 이름의 256이 바로 이 숫자예요.
+프랑스어, 네덜란드어, 독일어 문장을 넣었더니 프랑스어 '고양이 두 마리 사진'이 19.2%, 강아지와 자동차는 0%가 나왔습니다.
+재미있는 건, 실수로 영어 모델에 같은 문장을 넣었을 때는 29.5%가 나왔다는 점이에요. 그럼 영어 모델이 더 좋은 걸까요? 그렇지는 않습니다. 모델마다 학습된 온도 t와 바이어스 b가 달라서 확률 크기 자체를 모델끼리 비교하면 안 돼요.
+중요한 건 정답 캡션만 높고 나머지는 0으로 확실히 구분했다는 점이고, 한국어 질문을 쓸 5주차에는 이 다국어 모델을 후보로 써 볼 수 있습니다.</a:t>
             </a:r>
             <a:endParaRPr lang="en-US" dirty="0"/>
           </a:p>
@@ -14446,7 +14447,7 @@
                   <a:schemeClr val="tx1"/>
                 </a:solidFill>
               </a:rPr>
-              <a:t>실습 ④ 다른 언어로 물어보기</a:t>
+              <a:t>실습 ④ 다국어 모델로 물어보기</a:t>
             </a:r>
             <a:endParaRPr lang="en-US" sz="3000" dirty="0"/>
           </a:p>
@@ -14461,11 +14462,11 @@
         <p:spPr>
           <a:xfrm>
             <a:off x="640080" y="1325880"/>
-            <a:ext cx="6949440" cy="3429000"/>
+            <a:ext cx="6949440" cy="3246120"/>
           </a:xfrm>
           <a:prstGeom prst="roundRect">
             <a:avLst>
-              <a:gd name="adj" fmla="val 3200"/>
+              <a:gd name="adj" fmla="val 3380"/>
             </a:avLst>
           </a:prstGeom>
           <a:solidFill>
@@ -14483,7 +14484,7 @@
         <p:spPr>
           <a:xfrm>
             <a:off x="914400" y="1554480"/>
-            <a:ext cx="6400800" cy="2971800"/>
+            <a:ext cx="6400800" cy="2788920"/>
           </a:xfrm>
           <a:prstGeom prst="rect">
             <a:avLst/>
@@ -14504,13 +14505,13 @@
             <a:r>
               <a:rPr lang="en-US" sz="1200" dirty="0">
                 <a:solidFill>
-                  <a:srgbClr val="FBBF24"/>
+                  <a:schemeClr val="bg1"/>
                 </a:solidFill>
                 <a:latin typeface="Courier New" pitchFamily="34" charset="0"/>
                 <a:ea typeface="Courier New" pitchFamily="34" charset="-122"/>
                 <a:cs typeface="Courier New" pitchFamily="34" charset="-120"/>
               </a:rPr>
-              <a:t># from transformers import AutoProcessor, AutoModel</a:t>
+              <a:t>from transformers import AutoProcessor, AutoModel</a:t>
             </a:r>
             <a:endParaRPr lang="en-US" sz="1200" dirty="0"/>
           </a:p>
@@ -14524,13 +14525,13 @@
             <a:r>
               <a:rPr lang="en-US" sz="1200" dirty="0">
                 <a:solidFill>
-                  <a:srgbClr val="FBBF24"/>
+                  <a:schemeClr val="bg1"/>
                 </a:solidFill>
                 <a:latin typeface="Courier New" pitchFamily="34" charset="0"/>
                 <a:ea typeface="Courier New" pitchFamily="34" charset="-122"/>
                 <a:cs typeface="Courier New" pitchFamily="34" charset="-120"/>
               </a:rPr>
-              <a:t># processor = AutoProcessor.from_pretrained(</a:t>
+              <a:t>ckpt = "google/siglip-base-patch16-256-multilingual"</a:t>
             </a:r>
             <a:endParaRPr lang="en-US" sz="1200" dirty="0"/>
           </a:p>
@@ -14544,13 +14545,13 @@
             <a:r>
               <a:rPr lang="en-US" sz="1200" dirty="0">
                 <a:solidFill>
-                  <a:srgbClr val="FBBF24"/>
+                  <a:schemeClr val="bg1"/>
                 </a:solidFill>
                 <a:latin typeface="Courier New" pitchFamily="34" charset="0"/>
                 <a:ea typeface="Courier New" pitchFamily="34" charset="-122"/>
                 <a:cs typeface="Courier New" pitchFamily="34" charset="-120"/>
               </a:rPr>
-              <a:t>#     "google/siglip-so400m-patch14-384")</a:t>
+              <a:t>processor = AutoProcessor.from_pretrained(ckpt)</a:t>
             </a:r>
             <a:endParaRPr lang="en-US" sz="1200" dirty="0"/>
           </a:p>
@@ -14564,13 +14565,13 @@
             <a:r>
               <a:rPr lang="en-US" sz="1200" dirty="0">
                 <a:solidFill>
-                  <a:srgbClr val="FBBF24"/>
+                  <a:schemeClr val="bg1"/>
                 </a:solidFill>
                 <a:latin typeface="Courier New" pitchFamily="34" charset="0"/>
                 <a:ea typeface="Courier New" pitchFamily="34" charset="-122"/>
                 <a:cs typeface="Courier New" pitchFamily="34" charset="-120"/>
               </a:rPr>
-              <a:t># model = AutoModel.from_pretrained(</a:t>
+              <a:t>model = AutoModel.from_pretrained(ckpt)</a:t>
             </a:r>
             <a:endParaRPr lang="en-US" sz="1200" dirty="0"/>
           </a:p>
@@ -14584,13 +14585,13 @@
             <a:r>
               <a:rPr lang="en-US" sz="1200" dirty="0">
                 <a:solidFill>
-                  <a:srgbClr val="FBBF24"/>
+                  <a:schemeClr val="bg1"/>
                 </a:solidFill>
                 <a:latin typeface="Courier New" pitchFamily="34" charset="0"/>
                 <a:ea typeface="Courier New" pitchFamily="34" charset="-122"/>
                 <a:cs typeface="Courier New" pitchFamily="34" charset="-120"/>
               </a:rPr>
-              <a:t>#     "google/siglip-so400m-patch14-384")</a:t>
+              <a:t> </a:t>
             </a:r>
             <a:endParaRPr lang="en-US" sz="1200" dirty="0"/>
           </a:p>
@@ -14610,7 +14611,7 @@
                 <a:ea typeface="Courier New" pitchFamily="34" charset="-122"/>
                 <a:cs typeface="Courier New" pitchFamily="34" charset="-120"/>
               </a:rPr>
-              <a:t> </a:t>
+              <a:t>texts = ["une photo de 2 chats", "een foto met een hond",</a:t>
             </a:r>
             <a:endParaRPr lang="en-US" sz="1200" dirty="0"/>
           </a:p>
@@ -14630,7 +14631,7 @@
                 <a:ea typeface="Courier New" pitchFamily="34" charset="-122"/>
                 <a:cs typeface="Courier New" pitchFamily="34" charset="-120"/>
               </a:rPr>
-              <a:t>texts = ["une photo de 2 chats", "een foto met een hond",</a:t>
+              <a:t>         "ein Bild von einem Auto"]</a:t>
             </a:r>
             <a:endParaRPr lang="en-US" sz="1200" dirty="0"/>
           </a:p>
@@ -14650,7 +14651,7 @@
                 <a:ea typeface="Courier New" pitchFamily="34" charset="-122"/>
                 <a:cs typeface="Courier New" pitchFamily="34" charset="-120"/>
               </a:rPr>
-              <a:t>         "ein Bild von einem Auto"]</a:t>
+              <a:t>inputs = processor(text=texts, images=image,</a:t>
             </a:r>
             <a:endParaRPr lang="en-US" sz="1200" dirty="0"/>
           </a:p>
@@ -14670,7 +14671,7 @@
                 <a:ea typeface="Courier New" pitchFamily="34" charset="-122"/>
                 <a:cs typeface="Courier New" pitchFamily="34" charset="-120"/>
               </a:rPr>
-              <a:t>inputs = processor(text=texts, images=image,</a:t>
+              <a:t>                   padding="max_length", return_tensors="pt")</a:t>
             </a:r>
             <a:endParaRPr lang="en-US" sz="1200" dirty="0"/>
           </a:p>
@@ -14690,7 +14691,7 @@
                 <a:ea typeface="Courier New" pitchFamily="34" charset="-122"/>
                 <a:cs typeface="Courier New" pitchFamily="34" charset="-120"/>
               </a:rPr>
-              <a:t>                   padding="max_length", return_tensors="pt")</a:t>
+              <a:t>with torch.no_grad():</a:t>
             </a:r>
             <a:endParaRPr lang="en-US" sz="1200" dirty="0"/>
           </a:p>
@@ -14710,7 +14711,7 @@
                 <a:ea typeface="Courier New" pitchFamily="34" charset="-122"/>
                 <a:cs typeface="Courier New" pitchFamily="34" charset="-120"/>
               </a:rPr>
-              <a:t>with torch.no_grad():</a:t>
+              <a:t>  outputs = model(**inputs)</a:t>
             </a:r>
             <a:endParaRPr lang="en-US" sz="1200" dirty="0"/>
           </a:p>
@@ -14730,41 +14731,118 @@
                 <a:ea typeface="Courier New" pitchFamily="34" charset="-122"/>
                 <a:cs typeface="Courier New" pitchFamily="34" charset="-120"/>
               </a:rPr>
-              <a:t>  outputs = model(**inputs)</a:t>
+              <a:t>probs = torch.sigmoid(outputs.logits_per_image)</a:t>
             </a:r>
             <a:endParaRPr lang="en-US" sz="1200" dirty="0"/>
           </a:p>
-          <a:p>
-            <a:pPr indent="0" marL="0">
-              <a:lnSpc>
-                <a:spcPct val="110000"/>
-              </a:lnSpc>
+        </p:txBody>
+      </p:sp>
+      <p:sp>
+        <p:nvSpPr>
+          <p:cNvPr id="5" name="outbg-418"/>
+          <p:cNvSpPr/>
+          <p:nvPr/>
+        </p:nvSpPr>
+        <p:spPr>
+          <a:xfrm>
+            <a:off x="640080" y="4663440"/>
+            <a:ext cx="6949440" cy="868680"/>
+          </a:xfrm>
+          <a:prstGeom prst="roundRect">
+            <a:avLst>
+              <a:gd name="adj" fmla="val 8421"/>
+            </a:avLst>
+          </a:prstGeom>
+          <a:solidFill>
+            <a:schemeClr val="bg2"/>
+          </a:solidFill>
+          <a:ln w="12700">
+            <a:solidFill>
+              <a:schemeClr val="accent6"/>
+            </a:solidFill>
+            <a:prstDash val="solid"/>
+          </a:ln>
+        </p:spPr>
+      </p:sp>
+      <p:sp>
+        <p:nvSpPr>
+          <p:cNvPr id="6" name="text-419"/>
+          <p:cNvSpPr txBox="1"/>
+          <p:nvPr/>
+        </p:nvSpPr>
+        <p:spPr>
+          <a:xfrm>
+            <a:off x="822960" y="4754880"/>
+            <a:ext cx="6583680" cy="685800"/>
+          </a:xfrm>
+          <a:prstGeom prst="rect">
+            <a:avLst/>
+          </a:prstGeom>
+          <a:noFill/>
+          <a:ln/>
+        </p:spPr>
+        <p:txBody>
+          <a:bodyPr wrap="square" lIns="0" tIns="0" rIns="0" bIns="0" rtlCol="0" anchor="ctr"/>
+          <a:lstStyle/>
+          <a:p>
+            <a:pPr indent="0" marL="0">
+              <a:buNone/>
+            </a:pPr>
+            <a:r>
+              <a:rPr lang="en-US" sz="1100" b="1" dirty="0">
+                <a:solidFill>
+                  <a:schemeClr val="tx2"/>
+                </a:solidFill>
+              </a:rPr>
+              <a:t>출력</a:t>
+            </a:r>
+            <a:endParaRPr lang="en-US" sz="1200" dirty="0"/>
+          </a:p>
+          <a:p>
+            <a:pPr indent="0" marL="0">
               <a:buNone/>
             </a:pPr>
             <a:r>
               <a:rPr lang="en-US" sz="1200" dirty="0">
                 <a:solidFill>
-                  <a:schemeClr val="bg1"/>
+                  <a:schemeClr val="tx1"/>
                 </a:solidFill>
                 <a:latin typeface="Courier New" pitchFamily="34" charset="0"/>
                 <a:ea typeface="Courier New" pitchFamily="34" charset="-122"/>
                 <a:cs typeface="Courier New" pitchFamily="34" charset="-120"/>
               </a:rPr>
-              <a:t>probs = torch.sigmoid(outputs.logits_per_image)</a:t>
+              <a:t>pixel_values torch.Size([1, 3, 256, 256])  ← 다국어 모델은 256</a:t>
             </a:r>
             <a:endParaRPr lang="en-US" sz="1200" dirty="0"/>
           </a:p>
-        </p:txBody>
-      </p:sp>
-      <p:sp>
-        <p:nvSpPr>
-          <p:cNvPr id="5" name="text-418"/>
+          <a:p>
+            <a:pPr indent="0" marL="0">
+              <a:buNone/>
+            </a:pPr>
+            <a:r>
+              <a:rPr lang="en-US" sz="1200" dirty="0">
+                <a:solidFill>
+                  <a:schemeClr val="tx1"/>
+                </a:solidFill>
+                <a:latin typeface="Courier New" pitchFamily="34" charset="0"/>
+                <a:ea typeface="Courier New" pitchFamily="34" charset="-122"/>
+                <a:cs typeface="Courier New" pitchFamily="34" charset="-120"/>
+              </a:rPr>
+              <a:t>19.2% that image 0 is 'une photo de 2 chats'</a:t>
+            </a:r>
+            <a:endParaRPr lang="en-US" sz="1200" dirty="0"/>
+          </a:p>
+        </p:txBody>
+      </p:sp>
+      <p:sp>
+        <p:nvSpPr>
+          <p:cNvPr id="7" name="text-420"/>
           <p:cNvSpPr txBox="1"/>
           <p:nvPr/>
         </p:nvSpPr>
         <p:spPr>
           <a:xfrm>
-            <a:off x="640080" y="4846320"/>
+            <a:off x="640080" y="5623560"/>
             <a:ext cx="7315200" cy="292608"/>
           </a:xfrm>
           <a:prstGeom prst="rect">
@@ -14801,7 +14879,7 @@
                   </a:extLst>
                 </a:hlinkClick>
               </a:rPr>
-              <a:t>Inference with (multilingual) SigLIP 노트북 · 직접 실행 (base-patch16-224)</a:t>
+              <a:t>Inference with (multilingual) SigLIP 노트북 · 직접 실행 (base-patch16-256-multilingual)</a:t>
             </a:r>
             <a:endParaRPr lang="en-US" sz="1100" dirty="0"/>
           </a:p>
@@ -14809,7 +14887,7 @@
       </p:sp>
       <p:sp>
         <p:nvSpPr>
-          <p:cNvPr id="6" name="text-419"/>
+          <p:cNvPr id="8" name="text-421"/>
           <p:cNvSpPr txBox="1"/>
           <p:nvPr/>
         </p:nvSpPr>
@@ -14845,7 +14923,7 @@
       </p:sp>
       <p:sp>
         <p:nvSpPr>
-          <p:cNvPr id="7" name="bar-bg-420"/>
+          <p:cNvPr id="9" name="bar-bg-422"/>
           <p:cNvSpPr/>
           <p:nvPr/>
         </p:nvSpPr>
@@ -14865,14 +14943,14 @@
       </p:sp>
       <p:sp>
         <p:nvSpPr>
-          <p:cNvPr id="8" name="bar-421"/>
+          <p:cNvPr id="10" name="bar-423"/>
           <p:cNvSpPr/>
           <p:nvPr/>
         </p:nvSpPr>
         <p:spPr>
           <a:xfrm>
             <a:off x="7955280" y="1709928"/>
-            <a:ext cx="782269" cy="274320"/>
+            <a:ext cx="509138" cy="274320"/>
           </a:xfrm>
           <a:prstGeom prst="rect">
             <a:avLst/>
@@ -14885,7 +14963,7 @@
       </p:sp>
       <p:sp>
         <p:nvSpPr>
-          <p:cNvPr id="9" name="text-422"/>
+          <p:cNvPr id="11" name="text-424"/>
           <p:cNvSpPr txBox="1"/>
           <p:nvPr/>
         </p:nvSpPr>
@@ -14913,7 +14991,7 @@
                   <a:schemeClr val="accent5"/>
                 </a:solidFill>
               </a:rPr>
-              <a:t>29.5%</a:t>
+              <a:t>19.2%</a:t>
             </a:r>
             <a:endParaRPr lang="en-US" sz="1600" dirty="0"/>
           </a:p>
@@ -14921,13 +14999,13 @@
       </p:sp>
       <p:sp>
         <p:nvSpPr>
-          <p:cNvPr id="10" name="text-423"/>
+          <p:cNvPr id="12" name="text-425"/>
           <p:cNvSpPr txBox="1"/>
           <p:nvPr/>
         </p:nvSpPr>
         <p:spPr>
           <a:xfrm>
-            <a:off x="7955280" y="2103120"/>
+            <a:off x="7955280" y="2057400"/>
             <a:ext cx="3566160" cy="347472"/>
           </a:xfrm>
           <a:prstGeom prst="rect">
@@ -14957,13 +15035,13 @@
       </p:sp>
       <p:sp>
         <p:nvSpPr>
-          <p:cNvPr id="11" name="bar-bg-424"/>
+          <p:cNvPr id="13" name="bar-bg-426"/>
           <p:cNvSpPr/>
           <p:nvPr/>
         </p:nvSpPr>
         <p:spPr>
           <a:xfrm>
-            <a:off x="7955280" y="2487168"/>
+            <a:off x="7955280" y="2441448"/>
             <a:ext cx="2651760" cy="274320"/>
           </a:xfrm>
           <a:prstGeom prst="rect">
@@ -14977,13 +15055,13 @@
       </p:sp>
       <p:sp>
         <p:nvSpPr>
-          <p:cNvPr id="12" name="bar-425"/>
+          <p:cNvPr id="14" name="bar-427"/>
           <p:cNvSpPr/>
           <p:nvPr/>
         </p:nvSpPr>
         <p:spPr>
           <a:xfrm>
-            <a:off x="7955280" y="2487168"/>
+            <a:off x="7955280" y="2441448"/>
             <a:ext cx="36576" cy="274320"/>
           </a:xfrm>
           <a:prstGeom prst="rect">
@@ -14997,13 +15075,13 @@
       </p:sp>
       <p:sp>
         <p:nvSpPr>
-          <p:cNvPr id="13" name="text-426"/>
+          <p:cNvPr id="15" name="text-428"/>
           <p:cNvSpPr txBox="1"/>
           <p:nvPr/>
         </p:nvSpPr>
         <p:spPr>
           <a:xfrm>
-            <a:off x="10652760" y="2395728"/>
+            <a:off x="10652760" y="2350008"/>
             <a:ext cx="868680" cy="457200"/>
           </a:xfrm>
           <a:prstGeom prst="rect">
@@ -15033,13 +15111,13 @@
       </p:sp>
       <p:sp>
         <p:nvSpPr>
-          <p:cNvPr id="14" name="text-427"/>
+          <p:cNvPr id="16" name="text-429"/>
           <p:cNvSpPr txBox="1"/>
           <p:nvPr/>
         </p:nvSpPr>
         <p:spPr>
           <a:xfrm>
-            <a:off x="7955280" y="2880360"/>
+            <a:off x="7955280" y="2788920"/>
             <a:ext cx="3566160" cy="347472"/>
           </a:xfrm>
           <a:prstGeom prst="rect">
@@ -15069,13 +15147,13 @@
       </p:sp>
       <p:sp>
         <p:nvSpPr>
-          <p:cNvPr id="15" name="bar-bg-428"/>
+          <p:cNvPr id="17" name="bar-bg-430"/>
           <p:cNvSpPr/>
           <p:nvPr/>
         </p:nvSpPr>
         <p:spPr>
           <a:xfrm>
-            <a:off x="7955280" y="3264408"/>
+            <a:off x="7955280" y="3172968"/>
             <a:ext cx="2651760" cy="274320"/>
           </a:xfrm>
           <a:prstGeom prst="rect">
@@ -15089,13 +15167,13 @@
       </p:sp>
       <p:sp>
         <p:nvSpPr>
-          <p:cNvPr id="16" name="bar-429"/>
+          <p:cNvPr id="18" name="bar-431"/>
           <p:cNvSpPr/>
           <p:nvPr/>
         </p:nvSpPr>
         <p:spPr>
           <a:xfrm>
-            <a:off x="7955280" y="3264408"/>
+            <a:off x="7955280" y="3172968"/>
             <a:ext cx="36576" cy="274320"/>
           </a:xfrm>
           <a:prstGeom prst="rect">
@@ -15109,13 +15187,13 @@
       </p:sp>
       <p:sp>
         <p:nvSpPr>
-          <p:cNvPr id="17" name="text-430"/>
+          <p:cNvPr id="19" name="text-432"/>
           <p:cNvSpPr txBox="1"/>
           <p:nvPr/>
         </p:nvSpPr>
         <p:spPr>
           <a:xfrm>
-            <a:off x="10652760" y="3172968"/>
+            <a:off x="10652760" y="3081528"/>
             <a:ext cx="868680" cy="457200"/>
           </a:xfrm>
           <a:prstGeom prst="rect">
@@ -15145,23 +15223,23 @@
       </p:sp>
       <p:sp>
         <p:nvSpPr>
-          <p:cNvPr id="18" name="card-431"/>
+          <p:cNvPr id="20" name="card-433"/>
           <p:cNvSpPr/>
           <p:nvPr/>
         </p:nvSpPr>
         <p:spPr>
           <a:xfrm>
-            <a:off x="640080" y="5257800"/>
-            <a:ext cx="10881360" cy="822960"/>
+            <a:off x="7955280" y="3657600"/>
+            <a:ext cx="3566160" cy="2377440"/>
           </a:xfrm>
           <a:prstGeom prst="roundRect">
             <a:avLst>
-              <a:gd name="adj" fmla="val 15556"/>
+              <a:gd name="adj" fmla="val 5385"/>
             </a:avLst>
           </a:prstGeom>
           <a:solidFill>
-            <a:schemeClr val="accent4">
-              <a:alpha val="8000"/>
+            <a:schemeClr val="accent3">
+              <a:alpha val="10000"/>
             </a:schemeClr>
           </a:solidFill>
           <a:ln/>
@@ -15169,58 +15247,14 @@
       </p:sp>
       <p:sp>
         <p:nvSpPr>
-          <p:cNvPr id="19" name="circle-432"/>
-          <p:cNvSpPr/>
-          <p:nvPr/>
-        </p:nvSpPr>
-        <p:spPr>
-          <a:xfrm>
-            <a:off x="868680" y="5413248"/>
-            <a:ext cx="512064" cy="512064"/>
-          </a:xfrm>
-          <a:prstGeom prst="ellipse">
-            <a:avLst/>
-          </a:prstGeom>
-          <a:solidFill>
-            <a:schemeClr val="accent4"/>
-          </a:solidFill>
-          <a:ln/>
-        </p:spPr>
-      </p:sp>
-      <p:pic>
-        <p:nvPicPr>
-          <p:cNvPr id="20" name="icon-FaExclamationTriangle-433" descr="FaExclamationTriangle">    </p:cNvPr>
-          <p:cNvPicPr>
-            <a:picLocks noChangeAspect="1"/>
-          </p:cNvPicPr>
-          <p:nvPr/>
-        </p:nvPicPr>
-        <p:blipFill>
-          <a:blip r:embed="rId2"/>
-          <a:stretch>
-            <a:fillRect/>
-          </a:stretch>
-        </p:blipFill>
-        <p:spPr>
-          <a:xfrm>
-            <a:off x="1001817" y="5546385"/>
-            <a:ext cx="245791" cy="245791"/>
-          </a:xfrm>
-          <a:prstGeom prst="rect">
-            <a:avLst/>
-          </a:prstGeom>
-        </p:spPr>
-      </p:pic>
-      <p:sp>
-        <p:nvSpPr>
           <p:cNvPr id="21" name="text-434"/>
           <p:cNvSpPr txBox="1"/>
           <p:nvPr/>
         </p:nvSpPr>
         <p:spPr>
           <a:xfrm>
-            <a:off x="1554480" y="5257800"/>
-            <a:ext cx="9875520" cy="822960"/>
+            <a:off x="8138160" y="3657600"/>
+            <a:ext cx="3246120" cy="2377440"/>
           </a:xfrm>
           <a:prstGeom prst="rect">
             <a:avLst/>
@@ -15236,99 +15270,28 @@
               <a:buNone/>
             </a:pPr>
             <a:r>
-              <a:rPr lang="en-US" sz="1400" b="1" dirty="0">
-                <a:solidFill>
-                  <a:schemeClr val="accent4"/>
-                </a:solidFill>
-              </a:rPr>
-              <a:t>모델 로드가 주석 처리 → 이 결과는 영어 base 모델로 나온 값.  </a:t>
-            </a:r>
+              <a:rPr lang="en-US" sz="1600" b="1" dirty="0">
+                <a:solidFill>
+                  <a:schemeClr val="accent3"/>
+                </a:solidFill>
+              </a:rPr>
+              <a:t>영어 29.5% vs 다국어 19.2%?</a:t>
+            </a:r>
+            <a:endParaRPr lang="en-US" sz="1600" dirty="0"/>
+          </a:p>
+          <a:p>
+            <a:pPr indent="0" marL="0">
+              <a:buNone/>
+            </a:pPr>
             <a:r>
               <a:rPr lang="en-US" sz="1400" dirty="0">
                 <a:solidFill>
                   <a:schemeClr val="tx1"/>
                 </a:solidFill>
               </a:rPr>
-              <a:t>제대로 하려면 </a:t>
-            </a:r>
-            <a:r>
-              <a:rPr lang="en-US" sz="1400" b="1" dirty="0">
-                <a:solidFill>
-                  <a:schemeClr val="tx1"/>
-                </a:solidFill>
-                <a:latin typeface="Courier New" pitchFamily="34" charset="0"/>
-                <a:ea typeface="Courier New" pitchFamily="34" charset="-122"/>
-                <a:cs typeface="Courier New" pitchFamily="34" charset="-120"/>
-              </a:rPr>
-              <a:t>google/siglip-base-patch16-256-multilingual</a:t>
-            </a:r>
-            <a:r>
-              <a:rPr lang="en-US" sz="1400" dirty="0">
-                <a:solidFill>
-                  <a:schemeClr val="tx1"/>
-                </a:solidFill>
-              </a:rPr>
-              <a:t> 로 다시 실행</a:t>
-            </a:r>
-            <a:endParaRPr lang="en-US" sz="1400" dirty="0"/>
-          </a:p>
-        </p:txBody>
-      </p:sp>
-      <p:sp>
-        <p:nvSpPr>
-          <p:cNvPr id="22" name="card-435"/>
-          <p:cNvSpPr/>
-          <p:nvPr/>
-        </p:nvSpPr>
-        <p:spPr>
-          <a:xfrm>
-            <a:off x="7955280" y="3794760"/>
-            <a:ext cx="3566160" cy="1234440"/>
-          </a:xfrm>
-          <a:prstGeom prst="roundRect">
-            <a:avLst>
-              <a:gd name="adj" fmla="val 10370"/>
-            </a:avLst>
-          </a:prstGeom>
-          <a:solidFill>
-            <a:schemeClr val="bg2"/>
-          </a:solidFill>
-          <a:ln/>
-        </p:spPr>
-      </p:sp>
-      <p:sp>
-        <p:nvSpPr>
-          <p:cNvPr id="23" name="text-436"/>
-          <p:cNvSpPr txBox="1"/>
-          <p:nvPr/>
-        </p:nvSpPr>
-        <p:spPr>
-          <a:xfrm>
-            <a:off x="8138160" y="3794760"/>
-            <a:ext cx="3246120" cy="1234440"/>
-          </a:xfrm>
-          <a:prstGeom prst="rect">
-            <a:avLst/>
-          </a:prstGeom>
-          <a:noFill/>
-          <a:ln/>
-        </p:spPr>
-        <p:txBody>
-          <a:bodyPr wrap="square" lIns="0" tIns="0" rIns="0" bIns="0" rtlCol="0" anchor="ctr"/>
-          <a:lstStyle/>
-          <a:p>
-            <a:pPr indent="0" marL="0">
-              <a:buNone/>
-            </a:pPr>
-            <a:r>
-              <a:rPr lang="en-US" sz="1300" dirty="0">
-                <a:solidFill>
-                  <a:schemeClr val="tx1"/>
-                </a:solidFill>
-              </a:rPr>
-              <a:t>다국어 모델(mSigLIP): 영어로 거르지 않은 WebLI 데이터, 어휘 25만 토큰 → 한국어 질문 실험용</a:t>
-            </a:r>
-            <a:endParaRPr lang="en-US" sz="1300" dirty="0"/>
+              <a:t>모델마다 학습된 온도 t·바이어스 b가 달라서 확률의 크기를 모델끼리 비교하면 안 됨. 정답만 높고 나머지는 0 → 구분은 잘 함</a:t>
+            </a:r>
+            <a:endParaRPr lang="en-US" sz="1600" dirty="0"/>
           </a:p>
         </p:txBody>
       </p:sp>
@@ -15442,7 +15405,7 @@
       </p:sp>
       <p:sp>
         <p:nvSpPr>
-          <p:cNvPr id="3" name="codebg-437"/>
+          <p:cNvPr id="3" name="codebg-435"/>
           <p:cNvSpPr/>
           <p:nvPr/>
         </p:nvSpPr>
@@ -15464,7 +15427,7 @@
       </p:sp>
       <p:sp>
         <p:nvSpPr>
-          <p:cNvPr id="4" name="text-438"/>
+          <p:cNvPr id="4" name="text-436"/>
           <p:cNvSpPr txBox="1"/>
           <p:nvPr/>
         </p:nvSpPr>
@@ -15686,7 +15649,7 @@
       </p:sp>
       <p:sp>
         <p:nvSpPr>
-          <p:cNvPr id="5" name="outbg-439"/>
+          <p:cNvPr id="5" name="outbg-437"/>
           <p:cNvSpPr/>
           <p:nvPr/>
         </p:nvSpPr>
@@ -15713,7 +15676,7 @@
       </p:sp>
       <p:sp>
         <p:nvSpPr>
-          <p:cNvPr id="6" name="text-440"/>
+          <p:cNvPr id="6" name="text-438"/>
           <p:cNvSpPr txBox="1"/>
           <p:nvPr/>
         </p:nvSpPr>
@@ -15800,7 +15763,7 @@
       </p:sp>
       <p:sp>
         <p:nvSpPr>
-          <p:cNvPr id="7" name="text-441"/>
+          <p:cNvPr id="7" name="text-439"/>
           <p:cNvSpPr txBox="1"/>
           <p:nvPr/>
         </p:nvSpPr>
@@ -15851,7 +15814,7 @@
       </p:sp>
       <p:sp>
         <p:nvSpPr>
-          <p:cNvPr id="8" name="text-442"/>
+          <p:cNvPr id="8" name="text-440"/>
           <p:cNvSpPr txBox="1"/>
           <p:nvPr/>
         </p:nvSpPr>
@@ -15887,7 +15850,7 @@
       </p:sp>
       <p:sp>
         <p:nvSpPr>
-          <p:cNvPr id="9" name="bar-bg-443"/>
+          <p:cNvPr id="9" name="bar-bg-441"/>
           <p:cNvSpPr/>
           <p:nvPr/>
         </p:nvSpPr>
@@ -15907,7 +15870,7 @@
       </p:sp>
       <p:sp>
         <p:nvSpPr>
-          <p:cNvPr id="10" name="bar-444"/>
+          <p:cNvPr id="10" name="bar-442"/>
           <p:cNvSpPr/>
           <p:nvPr/>
         </p:nvSpPr>
@@ -15927,7 +15890,7 @@
       </p:sp>
       <p:sp>
         <p:nvSpPr>
-          <p:cNvPr id="11" name="text-445"/>
+          <p:cNvPr id="11" name="text-443"/>
           <p:cNvSpPr txBox="1"/>
           <p:nvPr/>
         </p:nvSpPr>
@@ -15963,7 +15926,7 @@
       </p:sp>
       <p:sp>
         <p:nvSpPr>
-          <p:cNvPr id="12" name="text-446"/>
+          <p:cNvPr id="12" name="text-444"/>
           <p:cNvSpPr txBox="1"/>
           <p:nvPr/>
         </p:nvSpPr>
@@ -15999,7 +15962,7 @@
       </p:sp>
       <p:sp>
         <p:nvSpPr>
-          <p:cNvPr id="13" name="bar-bg-447"/>
+          <p:cNvPr id="13" name="bar-bg-445"/>
           <p:cNvSpPr/>
           <p:nvPr/>
         </p:nvSpPr>
@@ -16019,7 +15982,7 @@
       </p:sp>
       <p:sp>
         <p:nvSpPr>
-          <p:cNvPr id="14" name="bar-448"/>
+          <p:cNvPr id="14" name="bar-446"/>
           <p:cNvSpPr/>
           <p:nvPr/>
         </p:nvSpPr>
@@ -16039,7 +16002,7 @@
       </p:sp>
       <p:sp>
         <p:nvSpPr>
-          <p:cNvPr id="15" name="text-449"/>
+          <p:cNvPr id="15" name="text-447"/>
           <p:cNvSpPr txBox="1"/>
           <p:nvPr/>
         </p:nvSpPr>
@@ -16075,7 +16038,7 @@
       </p:sp>
       <p:sp>
         <p:nvSpPr>
-          <p:cNvPr id="16" name="text-450"/>
+          <p:cNvPr id="16" name="text-448"/>
           <p:cNvSpPr txBox="1"/>
           <p:nvPr/>
         </p:nvSpPr>
@@ -16111,7 +16074,7 @@
       </p:sp>
       <p:sp>
         <p:nvSpPr>
-          <p:cNvPr id="17" name="bar-bg-451"/>
+          <p:cNvPr id="17" name="bar-bg-449"/>
           <p:cNvSpPr/>
           <p:nvPr/>
         </p:nvSpPr>
@@ -16131,7 +16094,7 @@
       </p:sp>
       <p:sp>
         <p:nvSpPr>
-          <p:cNvPr id="18" name="bar-452"/>
+          <p:cNvPr id="18" name="bar-450"/>
           <p:cNvSpPr/>
           <p:nvPr/>
         </p:nvSpPr>
@@ -16151,7 +16114,7 @@
       </p:sp>
       <p:sp>
         <p:nvSpPr>
-          <p:cNvPr id="19" name="text-453"/>
+          <p:cNvPr id="19" name="text-451"/>
           <p:cNvSpPr txBox="1"/>
           <p:nvPr/>
         </p:nvSpPr>
@@ -16187,7 +16150,7 @@
       </p:sp>
       <p:sp>
         <p:nvSpPr>
-          <p:cNvPr id="20" name="card-454"/>
+          <p:cNvPr id="20" name="card-452"/>
           <p:cNvSpPr/>
           <p:nvPr/>
         </p:nvSpPr>
@@ -16211,7 +16174,7 @@
       </p:sp>
       <p:sp>
         <p:nvSpPr>
-          <p:cNvPr id="21" name="text-455"/>
+          <p:cNvPr id="21" name="text-453"/>
           <p:cNvSpPr txBox="1"/>
           <p:nvPr/>
         </p:nvSpPr>
@@ -16369,7 +16332,7 @@
       </p:sp>
       <p:sp>
         <p:nvSpPr>
-          <p:cNvPr id="3" name="circle-456"/>
+          <p:cNvPr id="3" name="circle-454"/>
           <p:cNvSpPr/>
           <p:nvPr/>
         </p:nvSpPr>
@@ -16389,7 +16352,7 @@
       </p:sp>
       <p:pic>
         <p:nvPicPr>
-          <p:cNvPr id="4" name="icon-FaToggleOn-457" descr="FaToggleOn">    </p:cNvPr>
+          <p:cNvPr id="4" name="icon-FaToggleOn-455" descr="FaToggleOn">    </p:cNvPr>
           <p:cNvPicPr>
             <a:picLocks noChangeAspect="1"/>
           </p:cNvPicPr>
@@ -16413,7 +16376,7 @@
       </p:pic>
       <p:sp>
         <p:nvSpPr>
-          <p:cNvPr id="5" name="text-458"/>
+          <p:cNvPr id="5" name="text-456"/>
           <p:cNvSpPr txBox="1"/>
           <p:nvPr/>
         </p:nvSpPr>
@@ -16449,7 +16412,7 @@
       </p:sp>
       <p:sp>
         <p:nvSpPr>
-          <p:cNvPr id="6" name="text-459"/>
+          <p:cNvPr id="6" name="text-457"/>
           <p:cNvSpPr txBox="1"/>
           <p:nvPr/>
         </p:nvSpPr>
@@ -16485,7 +16448,7 @@
       </p:sp>
       <p:sp>
         <p:nvSpPr>
-          <p:cNvPr id="7" name="circle-460"/>
+          <p:cNvPr id="7" name="circle-458"/>
           <p:cNvSpPr/>
           <p:nvPr/>
         </p:nvSpPr>
@@ -16505,7 +16468,7 @@
       </p:sp>
       <p:pic>
         <p:nvPicPr>
-          <p:cNvPr id="8" name="icon-FaMemory-461" descr="FaMemory">    </p:cNvPr>
+          <p:cNvPr id="8" name="icon-FaMemory-459" descr="FaMemory">    </p:cNvPr>
           <p:cNvPicPr>
             <a:picLocks noChangeAspect="1"/>
           </p:cNvPicPr>
@@ -16529,7 +16492,7 @@
       </p:pic>
       <p:sp>
         <p:nvSpPr>
-          <p:cNvPr id="9" name="text-462"/>
+          <p:cNvPr id="9" name="text-460"/>
           <p:cNvSpPr txBox="1"/>
           <p:nvPr/>
         </p:nvSpPr>
@@ -16565,7 +16528,7 @@
       </p:sp>
       <p:sp>
         <p:nvSpPr>
-          <p:cNvPr id="10" name="text-463"/>
+          <p:cNvPr id="10" name="text-461"/>
           <p:cNvSpPr txBox="1"/>
           <p:nvPr/>
         </p:nvSpPr>
@@ -16601,7 +16564,7 @@
       </p:sp>
       <p:sp>
         <p:nvSpPr>
-          <p:cNvPr id="11" name="circle-464"/>
+          <p:cNvPr id="11" name="circle-462"/>
           <p:cNvSpPr/>
           <p:nvPr/>
         </p:nvSpPr>
@@ -16621,7 +16584,7 @@
       </p:sp>
       <p:pic>
         <p:nvPicPr>
-          <p:cNvPr id="12" name="icon-FaSearch-465" descr="FaSearch">    </p:cNvPr>
+          <p:cNvPr id="12" name="icon-FaSearch-463" descr="FaSearch">    </p:cNvPr>
           <p:cNvPicPr>
             <a:picLocks noChangeAspect="1"/>
           </p:cNvPicPr>
@@ -16645,7 +16608,7 @@
       </p:pic>
       <p:sp>
         <p:nvSpPr>
-          <p:cNvPr id="13" name="text-466"/>
+          <p:cNvPr id="13" name="text-464"/>
           <p:cNvSpPr txBox="1"/>
           <p:nvPr/>
         </p:nvSpPr>
@@ -16681,7 +16644,7 @@
       </p:sp>
       <p:sp>
         <p:nvSpPr>
-          <p:cNvPr id="14" name="text-467"/>
+          <p:cNvPr id="14" name="text-465"/>
           <p:cNvSpPr txBox="1"/>
           <p:nvPr/>
         </p:nvSpPr>
@@ -16825,7 +16788,7 @@
       </p:sp>
       <p:sp>
         <p:nvSpPr>
-          <p:cNvPr id="3" name="text-468"/>
+          <p:cNvPr id="3" name="text-466"/>
           <p:cNvSpPr txBox="1"/>
           <p:nvPr/>
         </p:nvSpPr>
@@ -16861,7 +16824,7 @@
       </p:sp>
       <p:sp>
         <p:nvSpPr>
-          <p:cNvPr id="4" name="text-469"/>
+          <p:cNvPr id="4" name="text-467"/>
           <p:cNvSpPr txBox="1"/>
           <p:nvPr/>
         </p:nvSpPr>
@@ -16904,7 +16867,7 @@
       </p:sp>
       <p:sp>
         <p:nvSpPr>
-          <p:cNvPr id="5" name="text-470"/>
+          <p:cNvPr id="5" name="text-468"/>
           <p:cNvSpPr txBox="1"/>
           <p:nvPr/>
         </p:nvSpPr>
@@ -16940,7 +16903,7 @@
       </p:sp>
       <p:sp>
         <p:nvSpPr>
-          <p:cNvPr id="6" name="text-471"/>
+          <p:cNvPr id="6" name="text-469"/>
           <p:cNvSpPr txBox="1"/>
           <p:nvPr/>
         </p:nvSpPr>
@@ -16983,7 +16946,7 @@
       </p:sp>
       <p:sp>
         <p:nvSpPr>
-          <p:cNvPr id="7" name="text-472"/>
+          <p:cNvPr id="7" name="text-470"/>
           <p:cNvSpPr txBox="1"/>
           <p:nvPr/>
         </p:nvSpPr>
@@ -17019,7 +16982,7 @@
       </p:sp>
       <p:sp>
         <p:nvSpPr>
-          <p:cNvPr id="8" name="text-473"/>
+          <p:cNvPr id="8" name="text-471"/>
           <p:cNvSpPr txBox="1"/>
           <p:nvPr/>
         </p:nvSpPr>
@@ -17062,7 +17025,7 @@
       </p:sp>
       <p:sp>
         <p:nvSpPr>
-          <p:cNvPr id="9" name="text-474"/>
+          <p:cNvPr id="9" name="text-472"/>
           <p:cNvSpPr txBox="1"/>
           <p:nvPr/>
         </p:nvSpPr>
@@ -17098,7 +17061,7 @@
       </p:sp>
       <p:sp>
         <p:nvSpPr>
-          <p:cNvPr id="10" name="text-475"/>
+          <p:cNvPr id="10" name="text-473"/>
           <p:cNvSpPr txBox="1"/>
           <p:nvPr/>
         </p:nvSpPr>
@@ -17141,7 +17104,7 @@
       </p:sp>
       <p:sp>
         <p:nvSpPr>
-          <p:cNvPr id="11" name="text-476"/>
+          <p:cNvPr id="11" name="text-474"/>
           <p:cNvSpPr txBox="1"/>
           <p:nvPr/>
         </p:nvSpPr>
@@ -17177,7 +17140,7 @@
       </p:sp>
       <p:sp>
         <p:nvSpPr>
-          <p:cNvPr id="12" name="text-477"/>
+          <p:cNvPr id="12" name="text-475"/>
           <p:cNvSpPr txBox="1"/>
           <p:nvPr/>
         </p:nvSpPr>
@@ -17220,7 +17183,7 @@
       </p:sp>
       <p:sp>
         <p:nvSpPr>
-          <p:cNvPr id="13" name="text-478"/>
+          <p:cNvPr id="13" name="text-476"/>
           <p:cNvSpPr txBox="1"/>
           <p:nvPr/>
         </p:nvSpPr>
@@ -17256,7 +17219,7 @@
       </p:sp>
       <p:sp>
         <p:nvSpPr>
-          <p:cNvPr id="14" name="text-479"/>
+          <p:cNvPr id="14" name="text-477"/>
           <p:cNvSpPr txBox="1"/>
           <p:nvPr/>
         </p:nvSpPr>
@@ -17299,7 +17262,7 @@
       </p:sp>
       <p:sp>
         <p:nvSpPr>
-          <p:cNvPr id="15" name="card-480"/>
+          <p:cNvPr id="15" name="card-478"/>
           <p:cNvSpPr/>
           <p:nvPr/>
         </p:nvSpPr>
@@ -17321,7 +17284,7 @@
       </p:sp>
       <p:sp>
         <p:nvSpPr>
-          <p:cNvPr id="16" name="text-481"/>
+          <p:cNvPr id="16" name="text-479"/>
           <p:cNvSpPr txBox="1"/>
           <p:nvPr/>
         </p:nvSpPr>

</xml_diff>